<commit_message>
Orange demo links in the deck
Co-Authored-By: Claude Opus 5.5 <noreply@anthropic.com>
</commit_message>
<xml_diff>
--- a/presentation/Pik-drishti_AI_Seva_2026.pptx
+++ b/presentation/Pik-drishti_AI_Seva_2026.pptx
@@ -9451,10 +9451,10 @@
         <a:srgbClr val="70AD47"/>
       </a:accent6>
       <a:hlink>
-        <a:srgbClr val="0563C1"/>
+        <a:srgbClr val="F28C28"/>
       </a:hlink>
       <a:folHlink>
-        <a:srgbClr val="954F72"/>
+        <a:srgbClr val="F28C28"/>
       </a:folHlink>
     </a:clrScheme>
     <a:fontScheme name="Office">

</xml_diff>